<commit_message>
docs: finalize 6-member team attribution, sync Project_Report.pdf and add to final/
</commit_message>
<xml_diff>
--- a/reports/Project_Presentation.pptx
+++ b/reports/Project_Presentation.pptx
@@ -3239,27 +3239,27 @@
               </a:defRPr>
             </a:pPr>
             <a:r>
-              <a:t>• Mayank Sharma (Project Lead &amp; AML Pipeline Architecture)</a:t>
+              <a:t>• Mayank Sharma (Lead – EDA &amp; Repository Management Lead)</a:t>
             </a:r>
             <a:br/>
             <a:r>
-              <a:t>• Team Member 2 (Literature Review, CCME WQI Math &amp; Regulatory Frameworks)</a:t>
+              <a:t>• Aman Soni (Model Training Lead – Baseline, RF, XGBoost)</a:t>
             </a:r>
             <a:br/>
             <a:r>
-              <a:t>• Team Member 3 (Multi-National Dataset Auditing &amp; Exploratory Data Analysis)</a:t>
+              <a:t>• Aaryan Gera (Data Preprocessing Lead – Cleaning &amp; Audit)</a:t>
             </a:r>
             <a:br/>
             <a:r>
-              <a:t>• Team Member 4 (Aquatic Chemical Feature Engineering &amp; Stoichiometric Physics)</a:t>
+              <a:t>• Chaitanya Kumar (Feature Engineering &amp; Stoichiometry Lead)</a:t>
             </a:r>
             <a:br/>
             <a:r>
-              <a:t>• Team Member 5 (Tree-Based Ensemble Optimization &amp; Validation Benchmarking)</a:t>
+              <a:t>• Ankit Kumar Pandey (Model Evaluation &amp; Validation Lead)</a:t>
             </a:r>
             <a:br/>
             <a:r>
-              <a:t>• Team Member 6 (Explainable AI via TreeSHAP, Metric Verification &amp; PyTest Suite)</a:t>
+              <a:t>• Pranav (Research, Documentation &amp; Presentation Lead)</a:t>
             </a:r>
           </a:p>
         </p:txBody>
@@ -5321,7 +5321,7 @@
               </a:defRPr>
             </a:pPr>
             <a:r>
-              <a:t>Mayank Sharma (Lead) — Pipeline Architecture &amp; Modeling</a:t>
+              <a:t>Mayank Sharma (Lead) — EDA &amp; Repository Management Lead</a:t>
             </a:r>
           </a:p>
           <a:p>
@@ -5333,7 +5333,7 @@
               </a:defRPr>
             </a:pPr>
             <a:r>
-              <a:t>Orchestrated end-to-end ML pipeline, Random Forest &amp; XGBoost modeling, Parquet sharding, and GitHub versioning.</a:t>
+              <a:t>Orchestrated end-to-end ML pipeline, data ingestion architecture, Parquet sharding, and anti-leakage quarantine.</a:t>
             </a:r>
           </a:p>
         </p:txBody>
@@ -5416,7 +5416,7 @@
               </a:defRPr>
             </a:pPr>
             <a:r>
-              <a:t>Team Member 2 — Literature Review &amp; Regulations</a:t>
+              <a:t>Aman Soni — Model Training Lead (RF, XGBoost)</a:t>
             </a:r>
           </a:p>
           <a:p>
@@ -5428,7 +5428,7 @@
               </a:defRPr>
             </a:pPr>
             <a:r>
-              <a:t>Synthesized ML environmental literature, derived CCME WQI formulation (F1, F2, F3, nse), and international standards.</a:t>
+              <a:t>Tuned tree ensembles, optimized loss functions and split criteria (MDI vs Gain), and led regression training.</a:t>
             </a:r>
           </a:p>
         </p:txBody>
@@ -5511,7 +5511,7 @@
               </a:defRPr>
             </a:pPr>
             <a:r>
-              <a:t>Team Member 3 — Dataset Auditing &amp; EDA</a:t>
+              <a:t>Aaryan Gera — Data Preprocessing Lead (Cleaning &amp; Audit)</a:t>
             </a:r>
           </a:p>
           <a:p>
@@ -5523,7 +5523,7 @@
               </a:defRPr>
             </a:pPr>
             <a:r>
-              <a:t>Executed multi-national dataset audit across 5 countries, detected telemetry anomalies, and established physics boundaries.</a:t>
+              <a:t>Executed 5-country dataset audit, enforced thermodynamic screening boundaries, and eliminated telemetry errors.</a:t>
             </a:r>
           </a:p>
         </p:txBody>
@@ -5606,7 +5606,7 @@
               </a:defRPr>
             </a:pPr>
             <a:r>
-              <a:t>Team Member 4 — Feature Engineering &amp; Chemistry</a:t>
+              <a:t>Chaitanya Kumar — Feature Engineering &amp; Stoichiometry Lead</a:t>
             </a:r>
           </a:p>
           <a:p>
@@ -5618,7 +5618,7 @@
               </a:defRPr>
             </a:pPr>
             <a:r>
-              <a:t>Engineered 38 features: Benson-Krause DO sat, Redfield N:P, Emerson toxic ammonia, log1p transforms, and station lags.</a:t>
+              <a:t>Engineered 38 features: Benson-Krause DO sat, Redfield N:P, Emerson toxic NH3, log(1+x) normalization, and station lags.</a:t>
             </a:r>
           </a:p>
         </p:txBody>
@@ -5701,7 +5701,7 @@
               </a:defRPr>
             </a:pPr>
             <a:r>
-              <a:t>Team Member 5 — Optimization &amp; Benchmarking</a:t>
+              <a:t>Ankit Kumar Pandey — Model Evaluation &amp; Validation Lead</a:t>
             </a:r>
           </a:p>
           <a:p>
@@ -5713,7 +5713,7 @@
               </a:defRPr>
             </a:pPr>
             <a:r>
-              <a:t>Managed hyperparameter optimization, loss functions, stratified 70/15/15 partitioning, and comparative benchmark metrics.</a:t>
+              <a:t>Managed stratified 70/15/15 partitioning, continuous metric benchmarks (MAE, RMSE, R²), and Dual-Head MLP evaluation.</a:t>
             </a:r>
           </a:p>
         </p:txBody>
@@ -5796,7 +5796,7 @@
               </a:defRPr>
             </a:pPr>
             <a:r>
-              <a:t>Team Member 6 — Explainability (XAI) &amp; Testing</a:t>
+              <a:t>Pranav — Research, Documentation &amp; Presentation Lead</a:t>
             </a:r>
           </a:p>
           <a:p>
@@ -5808,7 +5808,7 @@
               </a:defRPr>
             </a:pPr>
             <a:r>
-              <a:t>Conducted TreeSHAP attribution analysis, computed calibration metrics (Brier/ECE), and developed 12-test pytest suite.</a:t>
+              <a:t>Derived formal CCME WQI formulation (F1, F2, F3, nse), analyzed TreeSHAP attribution, and led viva preparation.</a:t>
             </a:r>
           </a:p>
         </p:txBody>

</xml_diff>

<commit_message>
docs: set Aman Soni as Project Lead and remove email addresses from report
</commit_message>
<xml_diff>
--- a/reports/Project_Presentation.pptx
+++ b/reports/Project_Presentation.pptx
@@ -3239,11 +3239,11 @@
               </a:defRPr>
             </a:pPr>
             <a:r>
-              <a:t>• Mayank Sharma (Lead – EDA &amp; Repository Management Lead)</a:t>
+              <a:t>• Aman Soni (Lead – Model Training Lead: RF, XGBoost)</a:t>
             </a:r>
             <a:br/>
             <a:r>
-              <a:t>• Aman Soni (Model Training Lead – Baseline, RF, XGBoost)</a:t>
+              <a:t>• Mayank Sharma (EDA &amp; Repository Management)</a:t>
             </a:r>
             <a:br/>
             <a:r>
@@ -5321,7 +5321,7 @@
               </a:defRPr>
             </a:pPr>
             <a:r>
-              <a:t>Mayank Sharma (Lead) — EDA &amp; Repository Management Lead</a:t>
+              <a:t>Aman Soni (Lead) — Model Training Lead (RF, XGBoost)</a:t>
             </a:r>
           </a:p>
           <a:p>
@@ -5333,7 +5333,7 @@
               </a:defRPr>
             </a:pPr>
             <a:r>
-              <a:t>Orchestrated end-to-end ML pipeline, data ingestion architecture, Parquet sharding, and anti-leakage quarantine.</a:t>
+              <a:t>Tuned tree ensembles, optimized loss functions and split criteria (MDI vs Gain), and led regression training.</a:t>
             </a:r>
           </a:p>
         </p:txBody>
@@ -5416,7 +5416,7 @@
               </a:defRPr>
             </a:pPr>
             <a:r>
-              <a:t>Aman Soni — Model Training Lead (RF, XGBoost)</a:t>
+              <a:t>Mayank Sharma — EDA &amp; Repository Management</a:t>
             </a:r>
           </a:p>
           <a:p>
@@ -5428,7 +5428,7 @@
               </a:defRPr>
             </a:pPr>
             <a:r>
-              <a:t>Tuned tree ensembles, optimized loss functions and split criteria (MDI vs Gain), and led regression training.</a:t>
+              <a:t>Orchestrated end-to-end ML pipeline, data ingestion architecture, Parquet sharding, and anti-leakage quarantine.</a:t>
             </a:r>
           </a:p>
         </p:txBody>

</xml_diff>